<commit_message>
feat: add PDF presentation templates and fix download links with dynamic base URL in Poster page
</commit_message>
<xml_diff>
--- a/Frontend/public/CHEMCONFLUX26 Oral Ppt template.pptx
+++ b/Frontend/public/CHEMCONFLUX26 Oral Ppt template.pptx
@@ -201,7 +201,7 @@
           <a:p>
             <a:fld id="{790BBA40-991C-4F27-9D56-D82596F71A0E}" type="datetime1">
               <a:rPr lang="en-IN" smtClean="0"/>
-              <a:t>07-10-2026</a:t>
+              <a:t>08-10-2026</a:t>
             </a:fld>
             <a:endParaRPr lang="en-IN"/>
           </a:p>
@@ -367,7 +367,7 @@
           <a:p>
             <a:fld id="{260BD55F-CA8F-406E-9431-7653448A5419}" type="datetime1">
               <a:rPr lang="en-IN" smtClean="0"/>
-              <a:t>07-10-2026</a:t>
+              <a:t>08-10-2026</a:t>
             </a:fld>
             <a:endParaRPr lang="en-IN"/>
           </a:p>
@@ -767,7 +767,7 @@
           <a:p>
             <a:fld id="{A6534B5E-AF0F-4476-93DF-4FD429AA2D51}" type="datetime1">
               <a:rPr lang="en-IN" smtClean="0"/>
-              <a:t>07-10-2026</a:t>
+              <a:t>08-10-2026</a:t>
             </a:fld>
             <a:endParaRPr lang="en-IN"/>
           </a:p>
@@ -937,7 +937,7 @@
           <a:p>
             <a:fld id="{5FA48DA6-E574-4C98-9318-F2D40230C490}" type="datetime1">
               <a:rPr lang="en-IN" smtClean="0"/>
-              <a:t>07-10-2026</a:t>
+              <a:t>08-10-2026</a:t>
             </a:fld>
             <a:endParaRPr lang="en-IN"/>
           </a:p>
@@ -1117,7 +1117,7 @@
           <a:p>
             <a:fld id="{D101976A-D614-49EB-8342-F0A15B6FA354}" type="datetime1">
               <a:rPr lang="en-IN" smtClean="0"/>
-              <a:t>07-10-2026</a:t>
+              <a:t>08-10-2026</a:t>
             </a:fld>
             <a:endParaRPr lang="en-IN"/>
           </a:p>
@@ -1287,7 +1287,7 @@
           <a:p>
             <a:fld id="{0C25DFD9-4091-43DF-88BB-0526875EAD18}" type="datetime1">
               <a:rPr lang="en-IN" smtClean="0"/>
-              <a:t>07-10-2026</a:t>
+              <a:t>08-10-2026</a:t>
             </a:fld>
             <a:endParaRPr lang="en-IN"/>
           </a:p>
@@ -1533,7 +1533,7 @@
           <a:p>
             <a:fld id="{70FA9F91-E494-442C-B1F6-A4A47325EA6D}" type="datetime1">
               <a:rPr lang="en-IN" smtClean="0"/>
-              <a:t>07-10-2026</a:t>
+              <a:t>08-10-2026</a:t>
             </a:fld>
             <a:endParaRPr lang="en-IN"/>
           </a:p>
@@ -1765,7 +1765,7 @@
           <a:p>
             <a:fld id="{603BEFE4-059F-4538-966B-95954E2DB786}" type="datetime1">
               <a:rPr lang="en-IN" smtClean="0"/>
-              <a:t>07-10-2026</a:t>
+              <a:t>08-10-2026</a:t>
             </a:fld>
             <a:endParaRPr lang="en-IN"/>
           </a:p>
@@ -2132,7 +2132,7 @@
           <a:p>
             <a:fld id="{1F79B10F-773D-4EF7-ACA3-782BA771F436}" type="datetime1">
               <a:rPr lang="en-IN" smtClean="0"/>
-              <a:t>07-10-2026</a:t>
+              <a:t>08-10-2026</a:t>
             </a:fld>
             <a:endParaRPr lang="en-IN"/>
           </a:p>
@@ -2250,7 +2250,7 @@
           <a:p>
             <a:fld id="{39F573A5-FF06-43E7-ADDC-41D5A4F78EB8}" type="datetime1">
               <a:rPr lang="en-IN" smtClean="0"/>
-              <a:t>07-10-2026</a:t>
+              <a:t>08-10-2026</a:t>
             </a:fld>
             <a:endParaRPr lang="en-IN"/>
           </a:p>
@@ -2345,7 +2345,7 @@
           <a:p>
             <a:fld id="{600D2D8B-CEEC-478F-934A-443B9DDCC6AC}" type="datetime1">
               <a:rPr lang="en-IN" smtClean="0"/>
-              <a:t>07-10-2026</a:t>
+              <a:t>08-10-2026</a:t>
             </a:fld>
             <a:endParaRPr lang="en-IN"/>
           </a:p>
@@ -2622,7 +2622,7 @@
           <a:p>
             <a:fld id="{C2BFE6B1-4A40-4FA0-9593-352D0C550E84}" type="datetime1">
               <a:rPr lang="en-IN" smtClean="0"/>
-              <a:t>07-10-2026</a:t>
+              <a:t>08-10-2026</a:t>
             </a:fld>
             <a:endParaRPr lang="en-IN"/>
           </a:p>
@@ -2875,7 +2875,7 @@
           <a:p>
             <a:fld id="{AE11E5FE-20EA-48FF-BB13-5D5ED17AD81C}" type="datetime1">
               <a:rPr lang="en-IN" smtClean="0"/>
-              <a:t>07-10-2026</a:t>
+              <a:t>08-10-2026</a:t>
             </a:fld>
             <a:endParaRPr lang="en-IN"/>
           </a:p>
@@ -3088,7 +3088,7 @@
           <a:p>
             <a:fld id="{8D827BFD-8C4F-481C-A712-10E2BF08DDBB}" type="datetime1">
               <a:rPr lang="en-IN" smtClean="0"/>
-              <a:t>07-10-2026</a:t>
+              <a:t>08-10-2026</a:t>
             </a:fld>
             <a:endParaRPr lang="en-IN"/>
           </a:p>
@@ -3496,51 +3496,6 @@
       </p:grpSpPr>
       <p:pic>
         <p:nvPicPr>
-          <p:cNvPr id="12" name="Picture 11">
-            <a:extLst>
-              <a:ext uri="{FF2B5EF4-FFF2-40B4-BE49-F238E27FC236}">
-                <a16:creationId xmlns:a16="http://schemas.microsoft.com/office/drawing/2014/main" id="{EC657B4E-6F8C-834D-60CC-69B282835D4C}"/>
-              </a:ext>
-            </a:extLst>
-          </p:cNvPr>
-          <p:cNvPicPr>
-            <a:picLocks noChangeAspect="1"/>
-          </p:cNvPicPr>
-          <p:nvPr/>
-        </p:nvPicPr>
-        <p:blipFill rotWithShape="1">
-          <a:blip r:embed="rId2" cstate="print">
-            <a:clrChange>
-              <a:clrFrom>
-                <a:srgbClr val="FFFFFF"/>
-              </a:clrFrom>
-              <a:clrTo>
-                <a:srgbClr val="FFFFFF">
-                  <a:alpha val="0"/>
-                </a:srgbClr>
-              </a:clrTo>
-            </a:clrChange>
-            <a:extLst>
-              <a:ext uri="{28A0092B-C50C-407E-A947-70E740481C1C}">
-                <a14:useLocalDpi xmlns:a14="http://schemas.microsoft.com/office/drawing/2010/main" val="0"/>
-              </a:ext>
-            </a:extLst>
-          </a:blip>
-          <a:srcRect t="16478" b="25291"/>
-          <a:stretch/>
-        </p:blipFill>
-        <p:spPr>
-          <a:xfrm>
-            <a:off x="10424160" y="348742"/>
-            <a:ext cx="1615440" cy="940697"/>
-          </a:xfrm>
-          <a:prstGeom prst="rect">
-            <a:avLst/>
-          </a:prstGeom>
-        </p:spPr>
-      </p:pic>
-      <p:pic>
-        <p:nvPicPr>
           <p:cNvPr id="13" name="Picture 12"/>
           <p:cNvPicPr>
             <a:picLocks noChangeAspect="1"/>
@@ -3548,7 +3503,7 @@
           <p:nvPr/>
         </p:nvPicPr>
         <p:blipFill>
-          <a:blip r:embed="rId3"/>
+          <a:blip r:embed="rId2"/>
           <a:stretch>
             <a:fillRect/>
           </a:stretch>
@@ -3603,19 +3558,16 @@
               <a:t>Title</a:t>
             </a:r>
             <a:r>
-              <a:rPr lang="en-US" sz="2000" b="1" dirty="0">
+              <a:rPr lang="en-US" sz="2000" b="1" dirty="0" smtClean="0">
                 <a:latin typeface="Arial" panose="020B0604020202020204" pitchFamily="34" charset="0"/>
                 <a:cs typeface="Arial" panose="020B0604020202020204" pitchFamily="34" charset="0"/>
               </a:rPr>
               <a:t>:</a:t>
             </a:r>
-            <a:r>
-              <a:rPr lang="en-US" sz="2000" dirty="0">
-                <a:latin typeface="Arial" panose="020B0604020202020204" pitchFamily="34" charset="0"/>
-                <a:cs typeface="Arial" panose="020B0604020202020204" pitchFamily="34" charset="0"/>
-              </a:rPr>
-              <a:t> </a:t>
-            </a:r>
+            <a:endParaRPr lang="en-US" sz="2000" dirty="0">
+              <a:latin typeface="Arial" panose="020B0604020202020204" pitchFamily="34" charset="0"/>
+              <a:cs typeface="Arial" panose="020B0604020202020204" pitchFamily="34" charset="0"/>
+            </a:endParaRPr>
           </a:p>
           <a:p>
             <a:pPr algn="just"/>
@@ -3704,7 +3656,7 @@
           <a:p>
             <a:fld id="{7F2CA1BD-616A-4EC6-B021-6C5E479642EE}" type="datetime1">
               <a:rPr lang="en-IN" smtClean="0"/>
-              <a:t>07-10-2026</a:t>
+              <a:t>08-10-2026</a:t>
             </a:fld>
             <a:endParaRPr lang="en-IN"/>
           </a:p>
@@ -3984,27 +3936,7 @@
                 <a:latin typeface="Arial" panose="020B0604020202020204" pitchFamily="34" charset="0"/>
                 <a:cs typeface="Arial" panose="020B0604020202020204" pitchFamily="34" charset="0"/>
               </a:rPr>
-              <a:t>Department </a:t>
-            </a:r>
-            <a:r>
-              <a:rPr lang="en-IN" sz="1400" b="1" dirty="0" smtClean="0">
-                <a:solidFill>
-                  <a:srgbClr val="002060"/>
-                </a:solidFill>
-                <a:latin typeface="Arial" panose="020B0604020202020204" pitchFamily="34" charset="0"/>
-                <a:cs typeface="Arial" panose="020B0604020202020204" pitchFamily="34" charset="0"/>
-              </a:rPr>
-              <a:t>of Chemical </a:t>
-            </a:r>
-            <a:r>
-              <a:rPr lang="en-IN" sz="1400" b="1" dirty="0" smtClean="0">
-                <a:solidFill>
-                  <a:srgbClr val="002060"/>
-                </a:solidFill>
-                <a:latin typeface="Arial" panose="020B0604020202020204" pitchFamily="34" charset="0"/>
-                <a:cs typeface="Arial" panose="020B0604020202020204" pitchFamily="34" charset="0"/>
-              </a:rPr>
-              <a:t>Engineering</a:t>
+              <a:t>Department of Chemical Engineering</a:t>
             </a:r>
           </a:p>
           <a:p>
@@ -4029,27 +3961,7 @@
                 <a:latin typeface="Arial" panose="020B0604020202020204" pitchFamily="34" charset="0"/>
                 <a:cs typeface="Arial" panose="020B0604020202020204" pitchFamily="34" charset="0"/>
               </a:rPr>
-              <a:t> </a:t>
-            </a:r>
-            <a:r>
-              <a:rPr lang="en-IN" sz="1400" b="1" dirty="0" smtClean="0">
-                <a:solidFill>
-                  <a:srgbClr val="002060"/>
-                </a:solidFill>
-                <a:latin typeface="Arial" panose="020B0604020202020204" pitchFamily="34" charset="0"/>
-                <a:cs typeface="Arial" panose="020B0604020202020204" pitchFamily="34" charset="0"/>
-              </a:rPr>
-              <a:t>Nehru National Institute of Technology (MNNIT) </a:t>
-            </a:r>
-            <a:r>
-              <a:rPr lang="en-IN" sz="1400" b="1" dirty="0" smtClean="0">
-                <a:solidFill>
-                  <a:srgbClr val="002060"/>
-                </a:solidFill>
-                <a:latin typeface="Arial" panose="020B0604020202020204" pitchFamily="34" charset="0"/>
-                <a:cs typeface="Arial" panose="020B0604020202020204" pitchFamily="34" charset="0"/>
-              </a:rPr>
-              <a:t>Allahabad,</a:t>
+              <a:t> Nehru National Institute of Technology (MNNIT) Allahabad,</a:t>
             </a:r>
             <a:r>
               <a:rPr lang="en-US" sz="1400" dirty="0">
@@ -4106,6 +4018,36 @@
           </a:p>
         </p:txBody>
       </p:sp>
+      <p:pic>
+        <p:nvPicPr>
+          <p:cNvPr id="2" name="Picture 1"/>
+          <p:cNvPicPr>
+            <a:picLocks noChangeAspect="1"/>
+          </p:cNvPicPr>
+          <p:nvPr/>
+        </p:nvPicPr>
+        <p:blipFill>
+          <a:blip r:embed="rId3" cstate="print">
+            <a:extLst>
+              <a:ext uri="{28A0092B-C50C-407E-A947-70E740481C1C}">
+                <a14:useLocalDpi xmlns:a14="http://schemas.microsoft.com/office/drawing/2010/main" val="0"/>
+              </a:ext>
+            </a:extLst>
+          </a:blip>
+          <a:stretch>
+            <a:fillRect/>
+          </a:stretch>
+        </p:blipFill>
+        <p:spPr>
+          <a:xfrm>
+            <a:off x="10465513" y="374469"/>
+            <a:ext cx="1635771" cy="854698"/>
+          </a:xfrm>
+          <a:prstGeom prst="rect">
+            <a:avLst/>
+          </a:prstGeom>
+        </p:spPr>
+      </p:pic>
     </p:spTree>
     <p:extLst>
       <p:ext uri="{BB962C8B-B14F-4D97-AF65-F5344CB8AC3E}">
@@ -4366,57 +4308,12 @@
           <a:p>
             <a:fld id="{BF7AE2A3-CAAE-45C6-874D-F54BBC1C723D}" type="datetime1">
               <a:rPr lang="en-IN" smtClean="0"/>
-              <a:t>07-10-2026</a:t>
+              <a:t>08-10-2026</a:t>
             </a:fld>
             <a:endParaRPr lang="en-IN"/>
           </a:p>
         </p:txBody>
       </p:sp>
-      <p:pic>
-        <p:nvPicPr>
-          <p:cNvPr id="8" name="Picture 7">
-            <a:extLst>
-              <a:ext uri="{FF2B5EF4-FFF2-40B4-BE49-F238E27FC236}">
-                <a16:creationId xmlns:a16="http://schemas.microsoft.com/office/drawing/2014/main" id="{EC657B4E-6F8C-834D-60CC-69B282835D4C}"/>
-              </a:ext>
-            </a:extLst>
-          </p:cNvPr>
-          <p:cNvPicPr>
-            <a:picLocks noChangeAspect="1"/>
-          </p:cNvPicPr>
-          <p:nvPr/>
-        </p:nvPicPr>
-        <p:blipFill rotWithShape="1">
-          <a:blip r:embed="rId2" cstate="print">
-            <a:clrChange>
-              <a:clrFrom>
-                <a:srgbClr val="FFFFFF"/>
-              </a:clrFrom>
-              <a:clrTo>
-                <a:srgbClr val="FFFFFF">
-                  <a:alpha val="0"/>
-                </a:srgbClr>
-              </a:clrTo>
-            </a:clrChange>
-            <a:extLst>
-              <a:ext uri="{28A0092B-C50C-407E-A947-70E740481C1C}">
-                <a14:useLocalDpi xmlns:a14="http://schemas.microsoft.com/office/drawing/2010/main" val="0"/>
-              </a:ext>
-            </a:extLst>
-          </a:blip>
-          <a:srcRect t="16478" b="25291"/>
-          <a:stretch/>
-        </p:blipFill>
-        <p:spPr>
-          <a:xfrm>
-            <a:off x="10424160" y="348742"/>
-            <a:ext cx="1615440" cy="940697"/>
-          </a:xfrm>
-          <a:prstGeom prst="rect">
-            <a:avLst/>
-          </a:prstGeom>
-        </p:spPr>
-      </p:pic>
       <p:pic>
         <p:nvPicPr>
           <p:cNvPr id="9" name="Picture 8"/>
@@ -4426,7 +4323,7 @@
           <p:nvPr/>
         </p:nvPicPr>
         <p:blipFill>
-          <a:blip r:embed="rId3"/>
+          <a:blip r:embed="rId2"/>
           <a:stretch>
             <a:fillRect/>
           </a:stretch>
@@ -4715,27 +4612,7 @@
                 <a:latin typeface="Arial" panose="020B0604020202020204" pitchFamily="34" charset="0"/>
                 <a:cs typeface="Arial" panose="020B0604020202020204" pitchFamily="34" charset="0"/>
               </a:rPr>
-              <a:t>Department </a:t>
-            </a:r>
-            <a:r>
-              <a:rPr lang="en-IN" sz="1400" b="1" dirty="0" smtClean="0">
-                <a:solidFill>
-                  <a:srgbClr val="002060"/>
-                </a:solidFill>
-                <a:latin typeface="Arial" panose="020B0604020202020204" pitchFamily="34" charset="0"/>
-                <a:cs typeface="Arial" panose="020B0604020202020204" pitchFamily="34" charset="0"/>
-              </a:rPr>
-              <a:t>of Chemical </a:t>
-            </a:r>
-            <a:r>
-              <a:rPr lang="en-IN" sz="1400" b="1" dirty="0" smtClean="0">
-                <a:solidFill>
-                  <a:srgbClr val="002060"/>
-                </a:solidFill>
-                <a:latin typeface="Arial" panose="020B0604020202020204" pitchFamily="34" charset="0"/>
-                <a:cs typeface="Arial" panose="020B0604020202020204" pitchFamily="34" charset="0"/>
-              </a:rPr>
-              <a:t>Engineering</a:t>
+              <a:t>Department of Chemical Engineering</a:t>
             </a:r>
           </a:p>
           <a:p>
@@ -4760,27 +4637,7 @@
                 <a:latin typeface="Arial" panose="020B0604020202020204" pitchFamily="34" charset="0"/>
                 <a:cs typeface="Arial" panose="020B0604020202020204" pitchFamily="34" charset="0"/>
               </a:rPr>
-              <a:t> </a:t>
-            </a:r>
-            <a:r>
-              <a:rPr lang="en-IN" sz="1400" b="1" dirty="0" smtClean="0">
-                <a:solidFill>
-                  <a:srgbClr val="002060"/>
-                </a:solidFill>
-                <a:latin typeface="Arial" panose="020B0604020202020204" pitchFamily="34" charset="0"/>
-                <a:cs typeface="Arial" panose="020B0604020202020204" pitchFamily="34" charset="0"/>
-              </a:rPr>
-              <a:t>Nehru National Institute of Technology (MNNIT) </a:t>
-            </a:r>
-            <a:r>
-              <a:rPr lang="en-IN" sz="1400" b="1" dirty="0" smtClean="0">
-                <a:solidFill>
-                  <a:srgbClr val="002060"/>
-                </a:solidFill>
-                <a:latin typeface="Arial" panose="020B0604020202020204" pitchFamily="34" charset="0"/>
-                <a:cs typeface="Arial" panose="020B0604020202020204" pitchFamily="34" charset="0"/>
-              </a:rPr>
-              <a:t>Allahabad,</a:t>
+              <a:t> Nehru National Institute of Technology (MNNIT) Allahabad,</a:t>
             </a:r>
             <a:r>
               <a:rPr lang="en-US" sz="1400" dirty="0">
@@ -4837,6 +4694,36 @@
           </a:p>
         </p:txBody>
       </p:sp>
+      <p:pic>
+        <p:nvPicPr>
+          <p:cNvPr id="10" name="Picture 9"/>
+          <p:cNvPicPr>
+            <a:picLocks noChangeAspect="1"/>
+          </p:cNvPicPr>
+          <p:nvPr/>
+        </p:nvPicPr>
+        <p:blipFill>
+          <a:blip r:embed="rId3" cstate="print">
+            <a:extLst>
+              <a:ext uri="{28A0092B-C50C-407E-A947-70E740481C1C}">
+                <a14:useLocalDpi xmlns:a14="http://schemas.microsoft.com/office/drawing/2010/main" val="0"/>
+              </a:ext>
+            </a:extLst>
+          </a:blip>
+          <a:stretch>
+            <a:fillRect/>
+          </a:stretch>
+        </p:blipFill>
+        <p:spPr>
+          <a:xfrm>
+            <a:off x="10465513" y="374469"/>
+            <a:ext cx="1635771" cy="854698"/>
+          </a:xfrm>
+          <a:prstGeom prst="rect">
+            <a:avLst/>
+          </a:prstGeom>
+        </p:spPr>
+      </p:pic>
     </p:spTree>
     <p:extLst>
       <p:ext uri="{BB962C8B-B14F-4D97-AF65-F5344CB8AC3E}">

</xml_diff>